<commit_message>
Add SharePoint delivery model, Excel manifest, and management overview deck
- README: document two delivery models (Git + SharePoint) with runbook
- cut-sprint.sh: split git/sharepoint handling; calls create_manifest_xlsx.py
- tag-environments.sh: reads manifest.xlsx; skips git ops for sharepoint teams
- close-sprint.sh: reads manifest.xlsx; skips merge/tag for sharepoint teams
- generate-report.py / generate-report.sh: switched from YAML to openpyxl
- create_manifest_xlsx.py: generates styled 4-sheet Excel manifest template
- populate_sprint12.py: sprint-12 demo data (conversion=sharepoint, 3 git teams)
- releases/sprint-12/manifest.xlsx: sprint-12 populated manifest
- releases/sprint-12/RELEASE-NOTES.md: regenerated from Excel manifest
- docs/management-overview.py + .pptx: new 8-slide management overview deck
- docs/generate_pptx.py / sprint-12-demo.pptx: layout fixes (spacing, slide 12, slide 10)

Co-Authored-By: Claude Sonnet 4.6 <noreply@anthropic.com>
</commit_message>
<xml_diff>
--- a/docs/sprint-12-demo.pptx
+++ b/docs/sprint-12-demo.pptx
@@ -3579,7 +3579,7 @@
         <p:spPr>
           <a:xfrm>
             <a:off x="320040" y="1234440"/>
-            <a:ext cx="3749039" cy="1463040"/>
+            <a:ext cx="3749039" cy="2194560"/>
           </a:xfrm>
           <a:prstGeom prst="rect">
             <a:avLst/>
@@ -3624,7 +3624,7 @@
         <p:spPr>
           <a:xfrm>
             <a:off x="320040" y="1234440"/>
-            <a:ext cx="3749039" cy="329184"/>
+            <a:ext cx="3749039" cy="347472"/>
           </a:xfrm>
           <a:prstGeom prst="rect">
             <a:avLst/>
@@ -3667,7 +3667,7 @@
         <p:spPr>
           <a:xfrm>
             <a:off x="411480" y="1271016"/>
-            <a:ext cx="3566159" cy="256032"/>
+            <a:ext cx="3566159" cy="274320"/>
           </a:xfrm>
           <a:prstGeom prst="rect">
             <a:avLst/>
@@ -3682,7 +3682,7 @@
           <a:p>
             <a:pPr algn="l"/>
             <a:r>
-              <a:rPr sz="1100" b="1" i="0">
+              <a:rPr sz="1200" b="1" i="0">
                 <a:solidFill>
                   <a:srgbClr val="FFFFFF"/>
                 </a:solidFill>
@@ -3700,8 +3700,8 @@
         </p:nvSpPr>
         <p:spPr>
           <a:xfrm>
-            <a:off x="429768" y="1636776"/>
-            <a:ext cx="3529583" cy="969264"/>
+            <a:off x="448056" y="1673352"/>
+            <a:ext cx="3493007" cy="1664208"/>
           </a:xfrm>
           <a:prstGeom prst="rect">
             <a:avLst/>
@@ -3716,7 +3716,7 @@
           <a:p>
             <a:pPr algn="l"/>
             <a:r>
-              <a:rPr sz="1050" b="0" i="0">
+              <a:rPr sz="1200" b="0" i="0">
                 <a:solidFill>
                   <a:srgbClr val="333333"/>
                 </a:solidFill>
@@ -3735,7 +3735,7 @@
         <p:spPr>
           <a:xfrm>
             <a:off x="4306823" y="1234440"/>
-            <a:ext cx="3749039" cy="1463040"/>
+            <a:ext cx="3749039" cy="2194560"/>
           </a:xfrm>
           <a:prstGeom prst="rect">
             <a:avLst/>
@@ -3780,7 +3780,7 @@
         <p:spPr>
           <a:xfrm>
             <a:off x="4306823" y="1234440"/>
-            <a:ext cx="3749039" cy="329184"/>
+            <a:ext cx="3749039" cy="347472"/>
           </a:xfrm>
           <a:prstGeom prst="rect">
             <a:avLst/>
@@ -3823,7 +3823,7 @@
         <p:spPr>
           <a:xfrm>
             <a:off x="4398263" y="1271016"/>
-            <a:ext cx="3566159" cy="256032"/>
+            <a:ext cx="3566159" cy="274320"/>
           </a:xfrm>
           <a:prstGeom prst="rect">
             <a:avLst/>
@@ -3838,7 +3838,7 @@
           <a:p>
             <a:pPr algn="l"/>
             <a:r>
-              <a:rPr sz="1100" b="1" i="0">
+              <a:rPr sz="1200" b="1" i="0">
                 <a:solidFill>
                   <a:srgbClr val="FFFFFF"/>
                 </a:solidFill>
@@ -3856,8 +3856,8 @@
         </p:nvSpPr>
         <p:spPr>
           <a:xfrm>
-            <a:off x="4416551" y="1636776"/>
-            <a:ext cx="3529583" cy="969264"/>
+            <a:off x="4434839" y="1673352"/>
+            <a:ext cx="3493007" cy="1664208"/>
           </a:xfrm>
           <a:prstGeom prst="rect">
             <a:avLst/>
@@ -3872,7 +3872,7 @@
           <a:p>
             <a:pPr algn="l"/>
             <a:r>
-              <a:rPr sz="1050" b="0" i="0">
+              <a:rPr sz="1200" b="0" i="0">
                 <a:solidFill>
                   <a:srgbClr val="333333"/>
                 </a:solidFill>
@@ -3891,7 +3891,7 @@
         <p:spPr>
           <a:xfrm>
             <a:off x="8293606" y="1234440"/>
-            <a:ext cx="3749039" cy="1463040"/>
+            <a:ext cx="3749039" cy="2194560"/>
           </a:xfrm>
           <a:prstGeom prst="rect">
             <a:avLst/>
@@ -3936,7 +3936,7 @@
         <p:spPr>
           <a:xfrm>
             <a:off x="8293606" y="1234440"/>
-            <a:ext cx="3749039" cy="329184"/>
+            <a:ext cx="3749039" cy="347472"/>
           </a:xfrm>
           <a:prstGeom prst="rect">
             <a:avLst/>
@@ -3979,7 +3979,7 @@
         <p:spPr>
           <a:xfrm>
             <a:off x="8385046" y="1271016"/>
-            <a:ext cx="3566159" cy="256032"/>
+            <a:ext cx="3566159" cy="274320"/>
           </a:xfrm>
           <a:prstGeom prst="rect">
             <a:avLst/>
@@ -3994,7 +3994,7 @@
           <a:p>
             <a:pPr algn="l"/>
             <a:r>
-              <a:rPr sz="1100" b="1" i="0">
+              <a:rPr sz="1200" b="1" i="0">
                 <a:solidFill>
                   <a:srgbClr val="FFFFFF"/>
                 </a:solidFill>
@@ -4012,8 +4012,8 @@
         </p:nvSpPr>
         <p:spPr>
           <a:xfrm>
-            <a:off x="8403334" y="1636776"/>
-            <a:ext cx="3529583" cy="969264"/>
+            <a:off x="8421622" y="1673352"/>
+            <a:ext cx="3493007" cy="1664208"/>
           </a:xfrm>
           <a:prstGeom prst="rect">
             <a:avLst/>
@@ -4028,7 +4028,7 @@
           <a:p>
             <a:pPr algn="l"/>
             <a:r>
-              <a:rPr sz="1050" b="0" i="0">
+              <a:rPr sz="1200" b="0" i="0">
                 <a:solidFill>
                   <a:srgbClr val="333333"/>
                 </a:solidFill>
@@ -4046,8 +4046,8 @@
         </p:nvSpPr>
         <p:spPr>
           <a:xfrm>
-            <a:off x="320040" y="2926080"/>
-            <a:ext cx="3749039" cy="1463040"/>
+            <a:off x="320040" y="3630168"/>
+            <a:ext cx="3749039" cy="2194560"/>
           </a:xfrm>
           <a:prstGeom prst="rect">
             <a:avLst/>
@@ -4091,8 +4091,8 @@
         </p:nvSpPr>
         <p:spPr>
           <a:xfrm>
-            <a:off x="320040" y="2926080"/>
-            <a:ext cx="3749039" cy="329184"/>
+            <a:off x="320040" y="3630168"/>
+            <a:ext cx="3749039" cy="347472"/>
           </a:xfrm>
           <a:prstGeom prst="rect">
             <a:avLst/>
@@ -4134,8 +4134,8 @@
         </p:nvSpPr>
         <p:spPr>
           <a:xfrm>
-            <a:off x="411480" y="2962656"/>
-            <a:ext cx="3566159" cy="256032"/>
+            <a:off x="411480" y="3666744"/>
+            <a:ext cx="3566159" cy="274320"/>
           </a:xfrm>
           <a:prstGeom prst="rect">
             <a:avLst/>
@@ -4150,7 +4150,7 @@
           <a:p>
             <a:pPr algn="l"/>
             <a:r>
-              <a:rPr sz="1100" b="1" i="0">
+              <a:rPr sz="1200" b="1" i="0">
                 <a:solidFill>
                   <a:srgbClr val="FFFFFF"/>
                 </a:solidFill>
@@ -4168,8 +4168,8 @@
         </p:nvSpPr>
         <p:spPr>
           <a:xfrm>
-            <a:off x="429768" y="3328416"/>
-            <a:ext cx="3529583" cy="969264"/>
+            <a:off x="448056" y="4069080"/>
+            <a:ext cx="3493007" cy="1664208"/>
           </a:xfrm>
           <a:prstGeom prst="rect">
             <a:avLst/>
@@ -4184,7 +4184,7 @@
           <a:p>
             <a:pPr algn="l"/>
             <a:r>
-              <a:rPr sz="1050" b="0" i="0">
+              <a:rPr sz="1200" b="0" i="0">
                 <a:solidFill>
                   <a:srgbClr val="333333"/>
                 </a:solidFill>
@@ -4202,8 +4202,8 @@
         </p:nvSpPr>
         <p:spPr>
           <a:xfrm>
-            <a:off x="4306823" y="2926080"/>
-            <a:ext cx="3749039" cy="1463040"/>
+            <a:off x="4306823" y="3630168"/>
+            <a:ext cx="3749039" cy="2194560"/>
           </a:xfrm>
           <a:prstGeom prst="rect">
             <a:avLst/>
@@ -4247,8 +4247,8 @@
         </p:nvSpPr>
         <p:spPr>
           <a:xfrm>
-            <a:off x="4306823" y="2926080"/>
-            <a:ext cx="3749039" cy="329184"/>
+            <a:off x="4306823" y="3630168"/>
+            <a:ext cx="3749039" cy="347472"/>
           </a:xfrm>
           <a:prstGeom prst="rect">
             <a:avLst/>
@@ -4290,8 +4290,8 @@
         </p:nvSpPr>
         <p:spPr>
           <a:xfrm>
-            <a:off x="4398263" y="2962656"/>
-            <a:ext cx="3566159" cy="256032"/>
+            <a:off x="4398263" y="3666744"/>
+            <a:ext cx="3566159" cy="274320"/>
           </a:xfrm>
           <a:prstGeom prst="rect">
             <a:avLst/>
@@ -4306,7 +4306,7 @@
           <a:p>
             <a:pPr algn="l"/>
             <a:r>
-              <a:rPr sz="1100" b="1" i="0">
+              <a:rPr sz="1200" b="1" i="0">
                 <a:solidFill>
                   <a:srgbClr val="FFFFFF"/>
                 </a:solidFill>
@@ -4324,8 +4324,8 @@
         </p:nvSpPr>
         <p:spPr>
           <a:xfrm>
-            <a:off x="4416551" y="3328416"/>
-            <a:ext cx="3529583" cy="969264"/>
+            <a:off x="4434839" y="4069080"/>
+            <a:ext cx="3493007" cy="1664208"/>
           </a:xfrm>
           <a:prstGeom prst="rect">
             <a:avLst/>
@@ -4340,7 +4340,7 @@
           <a:p>
             <a:pPr algn="l"/>
             <a:r>
-              <a:rPr sz="1050" b="0" i="0">
+              <a:rPr sz="1200" b="0" i="0">
                 <a:solidFill>
                   <a:srgbClr val="333333"/>
                 </a:solidFill>
@@ -4358,8 +4358,8 @@
         </p:nvSpPr>
         <p:spPr>
           <a:xfrm>
-            <a:off x="8293606" y="2926080"/>
-            <a:ext cx="3749039" cy="1463040"/>
+            <a:off x="8293606" y="3630168"/>
+            <a:ext cx="3749039" cy="2194560"/>
           </a:xfrm>
           <a:prstGeom prst="rect">
             <a:avLst/>
@@ -4403,8 +4403,8 @@
         </p:nvSpPr>
         <p:spPr>
           <a:xfrm>
-            <a:off x="8293606" y="2926080"/>
-            <a:ext cx="3749039" cy="329184"/>
+            <a:off x="8293606" y="3630168"/>
+            <a:ext cx="3749039" cy="347472"/>
           </a:xfrm>
           <a:prstGeom prst="rect">
             <a:avLst/>
@@ -4446,8 +4446,8 @@
         </p:nvSpPr>
         <p:spPr>
           <a:xfrm>
-            <a:off x="8385046" y="2962656"/>
-            <a:ext cx="3566159" cy="256032"/>
+            <a:off x="8385046" y="3666744"/>
+            <a:ext cx="3566159" cy="274320"/>
           </a:xfrm>
           <a:prstGeom prst="rect">
             <a:avLst/>
@@ -4462,7 +4462,7 @@
           <a:p>
             <a:pPr algn="l"/>
             <a:r>
-              <a:rPr sz="1100" b="1" i="0">
+              <a:rPr sz="1200" b="1" i="0">
                 <a:solidFill>
                   <a:srgbClr val="FFFFFF"/>
                 </a:solidFill>
@@ -4480,8 +4480,8 @@
         </p:nvSpPr>
         <p:spPr>
           <a:xfrm>
-            <a:off x="8403334" y="3328416"/>
-            <a:ext cx="3529583" cy="969264"/>
+            <a:off x="8421622" y="4069080"/>
+            <a:ext cx="3493007" cy="1664208"/>
           </a:xfrm>
           <a:prstGeom prst="rect">
             <a:avLst/>
@@ -4496,7 +4496,7 @@
           <a:p>
             <a:pPr algn="l"/>
             <a:r>
-              <a:rPr sz="1050" b="0" i="0">
+              <a:rPr sz="1200" b="0" i="0">
                 <a:solidFill>
                   <a:srgbClr val="333333"/>
                 </a:solidFill>
@@ -6028,13 +6028,81 @@
       </p:sp>
       <p:sp>
         <p:nvSpPr>
-          <p:cNvPr id="3" name="Rectangle 2"/>
+          <p:cNvPr id="3" name="TextBox 2"/>
+          <p:cNvSpPr txBox="1"/>
+          <p:nvPr/>
+        </p:nvSpPr>
+        <p:spPr>
+          <a:xfrm>
+            <a:off x="1097280" y="320040"/>
+            <a:ext cx="9966960" cy="685800"/>
+          </a:xfrm>
+          <a:prstGeom prst="rect">
+            <a:avLst/>
+          </a:prstGeom>
+          <a:noFill/>
+        </p:spPr>
+        <p:txBody>
+          <a:bodyPr wrap="square">
+            <a:spAutoFit/>
+          </a:bodyPr>
+          <a:lstStyle/>
+          <a:p>
+            <a:pPr algn="ctr"/>
+            <a:r>
+              <a:rPr sz="3200" b="1" i="0">
+                <a:solidFill>
+                  <a:srgbClr val="FFFFFF"/>
+                </a:solidFill>
+              </a:rPr>
+              <a:t>What This Prototype Demonstrates</a:t>
+            </a:r>
+          </a:p>
+        </p:txBody>
+      </p:sp>
+      <p:sp>
+        <p:nvSpPr>
+          <p:cNvPr id="4" name="TextBox 3"/>
+          <p:cNvSpPr txBox="1"/>
+          <p:nvPr/>
+        </p:nvSpPr>
+        <p:spPr>
+          <a:xfrm>
+            <a:off x="1097280" y="1005840"/>
+            <a:ext cx="9966960" cy="347472"/>
+          </a:xfrm>
+          <a:prstGeom prst="rect">
+            <a:avLst/>
+          </a:prstGeom>
+          <a:noFill/>
+        </p:spPr>
+        <p:txBody>
+          <a:bodyPr wrap="square">
+            <a:spAutoFit/>
+          </a:bodyPr>
+          <a:lstStyle/>
+          <a:p>
+            <a:pPr algn="ctr"/>
+            <a:r>
+              <a:rPr sz="1500" b="0" i="0">
+                <a:solidFill>
+                  <a:srgbClr val="BDD7EE"/>
+                </a:solidFill>
+              </a:rPr>
+              <a:t>Sprint-12 is fully prototyped with 5 live GitHub repositories</a:t>
+            </a:r>
+          </a:p>
+        </p:txBody>
+      </p:sp>
+      <p:sp>
+        <p:nvSpPr>
+          <p:cNvPr id="5" name="Rectangle 4"/>
           <p:cNvSpPr/>
           <p:nvPr/>
         </p:nvSpPr>
         <p:spPr>
           <a:xfrm>
-            <a:off x="0" y="1920240"/>
+            <a:off x="0" y="1463040"/>
             <a:ext cx="12188952" cy="54864"/>
           </a:xfrm>
           <a:prstGeom prst="rect">
@@ -6071,162 +6139,148 @@
       </p:sp>
       <p:sp>
         <p:nvSpPr>
-          <p:cNvPr id="4" name="TextBox 3"/>
-          <p:cNvSpPr txBox="1"/>
-          <p:nvPr/>
-        </p:nvSpPr>
-        <p:spPr>
-          <a:xfrm>
-            <a:off x="1097280" y="365760"/>
-            <a:ext cx="9966960" cy="685800"/>
-          </a:xfrm>
-          <a:prstGeom prst="rect">
-            <a:avLst/>
-          </a:prstGeom>
-          <a:noFill/>
-        </p:spPr>
-        <p:txBody>
-          <a:bodyPr wrap="square">
-            <a:spAutoFit/>
-          </a:bodyPr>
-          <a:lstStyle/>
-          <a:p>
-            <a:pPr algn="ctr"/>
-            <a:r>
-              <a:rPr sz="3000" b="1" i="0">
-                <a:solidFill>
-                  <a:srgbClr val="FFFFFF"/>
-                </a:solidFill>
-              </a:rPr>
-              <a:t>What This Prototype Demonstrates</a:t>
-            </a:r>
-          </a:p>
-        </p:txBody>
-      </p:sp>
-      <p:sp>
-        <p:nvSpPr>
-          <p:cNvPr id="5" name="TextBox 4"/>
-          <p:cNvSpPr txBox="1"/>
-          <p:nvPr/>
-        </p:nvSpPr>
-        <p:spPr>
-          <a:xfrm>
-            <a:off x="914400" y="2194560"/>
-            <a:ext cx="10332720" cy="3200400"/>
-          </a:xfrm>
-          <a:prstGeom prst="rect">
-            <a:avLst/>
-          </a:prstGeom>
-          <a:noFill/>
-        </p:spPr>
-        <p:txBody>
-          <a:bodyPr wrap="square">
-            <a:spAutoFit/>
-          </a:bodyPr>
-          <a:lstStyle/>
-          <a:p>
-            <a:pPr algn="l"/>
-            <a:r>
-              <a:rPr sz="1400" b="0" i="0">
+          <p:cNvPr id="6" name="TextBox 5"/>
+          <p:cNvSpPr txBox="1"/>
+          <p:nvPr/>
+        </p:nvSpPr>
+        <p:spPr>
+          <a:xfrm>
+            <a:off x="914400" y="1664208"/>
+            <a:ext cx="10332720" cy="3749039"/>
+          </a:xfrm>
+          <a:prstGeom prst="rect">
+            <a:avLst/>
+          </a:prstGeom>
+          <a:noFill/>
+        </p:spPr>
+        <p:txBody>
+          <a:bodyPr wrap="square">
+            <a:spAutoFit/>
+          </a:bodyPr>
+          <a:lstStyle/>
+          <a:p>
+            <a:pPr>
+              <a:spcAft>
+                <a:spcPts val="1400"/>
+              </a:spcAft>
+            </a:pPr>
+            <a:r>
+              <a:rPr sz="1500" b="0">
                 <a:solidFill>
                   <a:srgbClr val="BDD7EE"/>
                 </a:solidFill>
               </a:rPr>
-              <a:t>  ▸  End-to-end repeatable process from sprint cut to UAT close
-  ▸  CM controls all build decisions via a single manifest.yml — auditable, versioned, CM-gated
-  ▸  Teams work independently with zero cross-repo coordination overhead
-  ▸  Deferred teams never block a release — just set included: false
-  ▸  Environment state is always queryable: which commit is in SIT right now? Check the tag.
-  ▸  ELM traceability end-to-end: work item → feature branch → sprint branch → manifest → release tag
-  ▸  Mid-sprint removals handled cleanly via patch manifests, not branch surgery</a:t>
-            </a:r>
-          </a:p>
-        </p:txBody>
-      </p:sp>
-      <p:sp>
-        <p:nvSpPr>
-          <p:cNvPr id="6" name="TextBox 5"/>
-          <p:cNvSpPr txBox="1"/>
-          <p:nvPr/>
-        </p:nvSpPr>
-        <p:spPr>
-          <a:xfrm>
-            <a:off x="914400" y="5486400"/>
-            <a:ext cx="10332720" cy="292608"/>
-          </a:xfrm>
-          <a:prstGeom prst="rect">
-            <a:avLst/>
-          </a:prstGeom>
-          <a:noFill/>
-        </p:spPr>
-        <p:txBody>
-          <a:bodyPr wrap="square">
-            <a:spAutoFit/>
-          </a:bodyPr>
-          <a:lstStyle/>
-          <a:p>
-            <a:pPr algn="l"/>
-            <a:r>
-              <a:rPr sz="1200" b="1" i="0">
-                <a:solidFill>
-                  <a:srgbClr val="FFFFFF"/>
-                </a:solidFill>
-              </a:rPr>
-              <a:t>Repositories:</a:t>
-            </a:r>
-          </a:p>
-        </p:txBody>
-      </p:sp>
-      <p:sp>
-        <p:nvSpPr>
-          <p:cNvPr id="7" name="TextBox 6"/>
-          <p:cNvSpPr txBox="1"/>
-          <p:nvPr/>
-        </p:nvSpPr>
-        <p:spPr>
-          <a:xfrm>
-            <a:off x="914400" y="5806440"/>
-            <a:ext cx="10332720" cy="292608"/>
-          </a:xfrm>
-          <a:prstGeom prst="rect">
-            <a:avLst/>
-          </a:prstGeom>
-          <a:noFill/>
-        </p:spPr>
-        <p:txBody>
-          <a:bodyPr wrap="square">
-            <a:spAutoFit/>
-          </a:bodyPr>
-          <a:lstStyle/>
-          <a:p>
-            <a:pPr algn="ctr"/>
-            <a:r>
-              <a:rPr sz="1100" b="0" i="0">
-                <a:solidFill>
-                  <a:srgbClr val="9DB8D2"/>
-                </a:solidFill>
-              </a:rPr>
-              <a:t>github.com/satishreddy13  ·  repo-release-manifest  ·  repo-conversion  ·  repo-interfaces  ·  repo-workflow-config  ·  repo-func-config</a:t>
-            </a:r>
-          </a:p>
-        </p:txBody>
-      </p:sp>
-      <p:sp>
-        <p:nvSpPr>
-          <p:cNvPr id="8" name="Rectangle 7"/>
+              <a:t>• End-to-end repeatable process from sprint cut to UAT close</a:t>
+            </a:r>
+          </a:p>
+          <a:p>
+            <a:pPr>
+              <a:spcAft>
+                <a:spcPts val="1400"/>
+              </a:spcAft>
+            </a:pPr>
+            <a:r>
+              <a:rPr sz="1500" b="0">
+                <a:solidFill>
+                  <a:srgbClr val="BDD7EE"/>
+                </a:solidFill>
+              </a:rPr>
+              <a:t>• CM controls all build decisions via a single manifest.yml — auditable, versioned, CM-gated</a:t>
+            </a:r>
+          </a:p>
+          <a:p>
+            <a:pPr>
+              <a:spcAft>
+                <a:spcPts val="1400"/>
+              </a:spcAft>
+            </a:pPr>
+            <a:r>
+              <a:rPr sz="1500" b="0">
+                <a:solidFill>
+                  <a:srgbClr val="BDD7EE"/>
+                </a:solidFill>
+              </a:rPr>
+              <a:t>• Teams work independently with zero cross-repo coordination overhead</a:t>
+            </a:r>
+          </a:p>
+          <a:p>
+            <a:pPr>
+              <a:spcAft>
+                <a:spcPts val="1400"/>
+              </a:spcAft>
+            </a:pPr>
+            <a:r>
+              <a:rPr sz="1500" b="0">
+                <a:solidFill>
+                  <a:srgbClr val="BDD7EE"/>
+                </a:solidFill>
+              </a:rPr>
+              <a:t>• Deferred teams never block a release — just set included: false</a:t>
+            </a:r>
+          </a:p>
+          <a:p>
+            <a:pPr>
+              <a:spcAft>
+                <a:spcPts val="1400"/>
+              </a:spcAft>
+            </a:pPr>
+            <a:r>
+              <a:rPr sz="1500" b="0">
+                <a:solidFill>
+                  <a:srgbClr val="BDD7EE"/>
+                </a:solidFill>
+              </a:rPr>
+              <a:t>• Environment state is always queryable: which commit is in SIT right now?  Check the tag.</a:t>
+            </a:r>
+          </a:p>
+          <a:p>
+            <a:pPr>
+              <a:spcAft>
+                <a:spcPts val="1400"/>
+              </a:spcAft>
+            </a:pPr>
+            <a:r>
+              <a:rPr sz="1500" b="0">
+                <a:solidFill>
+                  <a:srgbClr val="BDD7EE"/>
+                </a:solidFill>
+              </a:rPr>
+              <a:t>• ELM traceability end-to-end: work item → feature branch → sprint branch → manifest → release tag</a:t>
+            </a:r>
+          </a:p>
+          <a:p>
+            <a:pPr>
+              <a:spcAft>
+                <a:spcPts val="1400"/>
+              </a:spcAft>
+            </a:pPr>
+            <a:r>
+              <a:rPr sz="1500" b="0">
+                <a:solidFill>
+                  <a:srgbClr val="BDD7EE"/>
+                </a:solidFill>
+              </a:rPr>
+              <a:t>• Mid-sprint removals handled cleanly via patch manifests, not branch surgery</a:t>
+            </a:r>
+          </a:p>
+        </p:txBody>
+      </p:sp>
+      <p:sp>
+        <p:nvSpPr>
+          <p:cNvPr id="7" name="Rectangle 6"/>
           <p:cNvSpPr/>
           <p:nvPr/>
         </p:nvSpPr>
         <p:spPr>
           <a:xfrm>
-            <a:off x="0" y="6601968"/>
-            <a:ext cx="12188952" cy="256032"/>
-          </a:xfrm>
-          <a:prstGeom prst="rect">
-            <a:avLst/>
-          </a:prstGeom>
-          <a:solidFill>
-            <a:srgbClr val="1A233A"/>
+            <a:off x="0" y="5577840"/>
+            <a:ext cx="12188952" cy="594360"/>
+          </a:xfrm>
+          <a:prstGeom prst="rect">
+            <a:avLst/>
+          </a:prstGeom>
+          <a:solidFill>
+            <a:srgbClr val="101828"/>
           </a:solidFill>
           <a:ln>
             <a:noFill/>
@@ -6256,7 +6310,118 @@
       </p:sp>
       <p:sp>
         <p:nvSpPr>
+          <p:cNvPr id="8" name="TextBox 7"/>
+          <p:cNvSpPr txBox="1"/>
+          <p:nvPr/>
+        </p:nvSpPr>
+        <p:spPr>
+          <a:xfrm>
+            <a:off x="365760" y="5623560"/>
+            <a:ext cx="1463040" cy="256032"/>
+          </a:xfrm>
+          <a:prstGeom prst="rect">
+            <a:avLst/>
+          </a:prstGeom>
+          <a:noFill/>
+        </p:spPr>
+        <p:txBody>
+          <a:bodyPr wrap="square">
+            <a:spAutoFit/>
+          </a:bodyPr>
+          <a:lstStyle/>
+          <a:p>
+            <a:pPr algn="l"/>
+            <a:r>
+              <a:rPr sz="1100" b="1" i="0">
+                <a:solidFill>
+                  <a:srgbClr val="9DB8D2"/>
+                </a:solidFill>
+              </a:rPr>
+              <a:t>Repositories</a:t>
+            </a:r>
+          </a:p>
+        </p:txBody>
+      </p:sp>
+      <p:sp>
+        <p:nvSpPr>
           <p:cNvPr id="9" name="TextBox 8"/>
+          <p:cNvSpPr txBox="1"/>
+          <p:nvPr/>
+        </p:nvSpPr>
+        <p:spPr>
+          <a:xfrm>
+            <a:off x="365760" y="5879592"/>
+            <a:ext cx="11521440" cy="237744"/>
+          </a:xfrm>
+          <a:prstGeom prst="rect">
+            <a:avLst/>
+          </a:prstGeom>
+          <a:noFill/>
+        </p:spPr>
+        <p:txBody>
+          <a:bodyPr wrap="square">
+            <a:spAutoFit/>
+          </a:bodyPr>
+          <a:lstStyle/>
+          <a:p>
+            <a:pPr algn="ctr"/>
+            <a:r>
+              <a:rPr sz="1100" b="0" i="0">
+                <a:solidFill>
+                  <a:srgbClr val="7BA8CC"/>
+                </a:solidFill>
+              </a:rPr>
+              <a:t>github.com/satishreddy13  •  repo-release-manifest  •  repo-conversion  •  repo-interfaces  •  repo-workflow-config  •  repo-func-config</a:t>
+            </a:r>
+          </a:p>
+        </p:txBody>
+      </p:sp>
+      <p:sp>
+        <p:nvSpPr>
+          <p:cNvPr id="10" name="Rectangle 9"/>
+          <p:cNvSpPr/>
+          <p:nvPr/>
+        </p:nvSpPr>
+        <p:spPr>
+          <a:xfrm>
+            <a:off x="0" y="6601968"/>
+            <a:ext cx="12188952" cy="256032"/>
+          </a:xfrm>
+          <a:prstGeom prst="rect">
+            <a:avLst/>
+          </a:prstGeom>
+          <a:solidFill>
+            <a:srgbClr val="1A233A"/>
+          </a:solidFill>
+          <a:ln>
+            <a:noFill/>
+          </a:ln>
+        </p:spPr>
+        <p:style>
+          <a:lnRef idx="1">
+            <a:schemeClr val="accent1"/>
+          </a:lnRef>
+          <a:fillRef idx="3">
+            <a:schemeClr val="accent1"/>
+          </a:fillRef>
+          <a:effectRef idx="2">
+            <a:schemeClr val="accent1"/>
+          </a:effectRef>
+          <a:fontRef idx="minor">
+            <a:schemeClr val="lt1"/>
+          </a:fontRef>
+        </p:style>
+        <p:txBody>
+          <a:bodyPr rtlCol="0" anchor="ctr"/>
+          <a:lstStyle/>
+          <a:p>
+            <a:pPr algn="ctr"/>
+          </a:p>
+        </p:txBody>
+      </p:sp>
+      <p:sp>
+        <p:nvSpPr>
+          <p:cNvPr id="11" name="TextBox 10"/>
           <p:cNvSpPr txBox="1"/>
           <p:nvPr/>
         </p:nvSpPr>
@@ -9916,19 +10081,93 @@
           </a:bodyPr>
           <a:lstStyle/>
           <a:p>
-            <a:pPr algn="l"/>
-            <a:r>
-              <a:rPr sz="1300" b="0" i="0">
+            <a:pPr>
+              <a:spcAft>
+                <a:spcPts val="600"/>
+              </a:spcAft>
+            </a:pPr>
+            <a:r>
+              <a:rPr sz="1300" b="0">
                 <a:solidFill>
                   <a:srgbClr val="333333"/>
                 </a:solidFill>
               </a:rPr>
-              <a:t>▸  Fetches latest main in each team repo
-▸  Creates sprint/sprint-12 branch from main
-▸  Pushes the branch to GitHub
-▸  Scaffolds releases/sprint-12/manifest.yml from template
-▸  Scaffolds releases/sprint-12/cots-sprint-12.md
-▸  Creates placeholder RELEASE-NOTES.md</a:t>
+              <a:t>• Fetches latest main in each team repo</a:t>
+            </a:r>
+          </a:p>
+          <a:p>
+            <a:pPr>
+              <a:spcAft>
+                <a:spcPts val="600"/>
+              </a:spcAft>
+            </a:pPr>
+            <a:r>
+              <a:rPr sz="1300" b="0">
+                <a:solidFill>
+                  <a:srgbClr val="333333"/>
+                </a:solidFill>
+              </a:rPr>
+              <a:t>• Creates sprint/sprint-12 branch from main</a:t>
+            </a:r>
+          </a:p>
+          <a:p>
+            <a:pPr>
+              <a:spcAft>
+                <a:spcPts val="600"/>
+              </a:spcAft>
+            </a:pPr>
+            <a:r>
+              <a:rPr sz="1300" b="0">
+                <a:solidFill>
+                  <a:srgbClr val="333333"/>
+                </a:solidFill>
+              </a:rPr>
+              <a:t>• Pushes the branch to GitHub</a:t>
+            </a:r>
+          </a:p>
+          <a:p>
+            <a:pPr>
+              <a:spcAft>
+                <a:spcPts val="600"/>
+              </a:spcAft>
+            </a:pPr>
+            <a:r>
+              <a:rPr sz="1300" b="0">
+                <a:solidFill>
+                  <a:srgbClr val="333333"/>
+                </a:solidFill>
+              </a:rPr>
+              <a:t>• Scaffolds releases/sprint-12/manifest.yml from template</a:t>
+            </a:r>
+          </a:p>
+          <a:p>
+            <a:pPr>
+              <a:spcAft>
+                <a:spcPts val="600"/>
+              </a:spcAft>
+            </a:pPr>
+            <a:r>
+              <a:rPr sz="1300" b="0">
+                <a:solidFill>
+                  <a:srgbClr val="333333"/>
+                </a:solidFill>
+              </a:rPr>
+              <a:t>• Scaffolds releases/sprint-12/cots-sprint-12.md</a:t>
+            </a:r>
+          </a:p>
+          <a:p>
+            <a:pPr>
+              <a:spcAft>
+                <a:spcPts val="600"/>
+              </a:spcAft>
+            </a:pPr>
+            <a:r>
+              <a:rPr sz="1300" b="0">
+                <a:solidFill>
+                  <a:srgbClr val="333333"/>
+                </a:solidFill>
+              </a:rPr>
+              <a:t>• Creates placeholder RELEASE-NOTES.md</a:t>
             </a:r>
           </a:p>
         </p:txBody>
@@ -13737,19 +13976,93 @@
           </a:bodyPr>
           <a:lstStyle/>
           <a:p>
-            <a:pPr algn="l"/>
-            <a:r>
-              <a:rPr sz="1300" b="0" i="0">
+            <a:pPr>
+              <a:spcAft>
+                <a:spcPts val="600"/>
+              </a:spcAft>
+            </a:pPr>
+            <a:r>
+              <a:rPr sz="1300" b="0">
                 <a:solidFill>
                   <a:srgbClr val="333333"/>
                 </a:solidFill>
               </a:rPr>
-              <a:t>▸  Committed to repo-release-manifest
-▸  PR raised for CM team review (CODEOWNERS)
-▸  Shared with stakeholders as official build record
-▸  Audit trail: who built what, from which commit
-▸  Deferred teams logged — tracked to next sprint
-▸  COTS hotfixes documented for compliance</a:t>
+              <a:t>• Committed to repo-release-manifest</a:t>
+            </a:r>
+          </a:p>
+          <a:p>
+            <a:pPr>
+              <a:spcAft>
+                <a:spcPts val="600"/>
+              </a:spcAft>
+            </a:pPr>
+            <a:r>
+              <a:rPr sz="1300" b="0">
+                <a:solidFill>
+                  <a:srgbClr val="333333"/>
+                </a:solidFill>
+              </a:rPr>
+              <a:t>• PR raised for CM team review (CODEOWNERS)</a:t>
+            </a:r>
+          </a:p>
+          <a:p>
+            <a:pPr>
+              <a:spcAft>
+                <a:spcPts val="600"/>
+              </a:spcAft>
+            </a:pPr>
+            <a:r>
+              <a:rPr sz="1300" b="0">
+                <a:solidFill>
+                  <a:srgbClr val="333333"/>
+                </a:solidFill>
+              </a:rPr>
+              <a:t>• Shared with stakeholders as official build record</a:t>
+            </a:r>
+          </a:p>
+          <a:p>
+            <a:pPr>
+              <a:spcAft>
+                <a:spcPts val="600"/>
+              </a:spcAft>
+            </a:pPr>
+            <a:r>
+              <a:rPr sz="1300" b="0">
+                <a:solidFill>
+                  <a:srgbClr val="333333"/>
+                </a:solidFill>
+              </a:rPr>
+              <a:t>• Audit trail: who built what, from which commit</a:t>
+            </a:r>
+          </a:p>
+          <a:p>
+            <a:pPr>
+              <a:spcAft>
+                <a:spcPts val="600"/>
+              </a:spcAft>
+            </a:pPr>
+            <a:r>
+              <a:rPr sz="1300" b="0">
+                <a:solidFill>
+                  <a:srgbClr val="333333"/>
+                </a:solidFill>
+              </a:rPr>
+              <a:t>• Deferred teams logged — tracked to next sprint</a:t>
+            </a:r>
+          </a:p>
+          <a:p>
+            <a:pPr>
+              <a:spcAft>
+                <a:spcPts val="600"/>
+              </a:spcAft>
+            </a:pPr>
+            <a:r>
+              <a:rPr sz="1300" b="0">
+                <a:solidFill>
+                  <a:srgbClr val="333333"/>
+                </a:solidFill>
+              </a:rPr>
+              <a:t>• COTS hotfixes documented for compliance</a:t>
             </a:r>
           </a:p>
         </p:txBody>
@@ -14917,18 +15230,78 @@
           </a:bodyPr>
           <a:lstStyle/>
           <a:p>
-            <a:pPr algn="l"/>
-            <a:r>
-              <a:rPr sz="1300" b="0" i="0">
+            <a:pPr>
+              <a:spcAft>
+                <a:spcPts val="600"/>
+              </a:spcAft>
+            </a:pPr>
+            <a:r>
+              <a:rPr sz="1300" b="0">
                 <a:solidFill>
                   <a:srgbClr val="333333"/>
                 </a:solidFill>
               </a:rPr>
-              <a:t>▸  Survives branch deletion after sprint close
-▸  Tells ops exactly what code is in each env
-▸  Auditable: tag message records who deployed when
-▸  Enables rollback: redeploy from tag at any time
-▸  Patch releases get their own tag (sprint-12-patch1)</a:t>
+              <a:t>• Survives branch deletion after sprint close</a:t>
+            </a:r>
+          </a:p>
+          <a:p>
+            <a:pPr>
+              <a:spcAft>
+                <a:spcPts val="600"/>
+              </a:spcAft>
+            </a:pPr>
+            <a:r>
+              <a:rPr sz="1300" b="0">
+                <a:solidFill>
+                  <a:srgbClr val="333333"/>
+                </a:solidFill>
+              </a:rPr>
+              <a:t>• Tells ops exactly what code is in each env</a:t>
+            </a:r>
+          </a:p>
+          <a:p>
+            <a:pPr>
+              <a:spcAft>
+                <a:spcPts val="600"/>
+              </a:spcAft>
+            </a:pPr>
+            <a:r>
+              <a:rPr sz="1300" b="0">
+                <a:solidFill>
+                  <a:srgbClr val="333333"/>
+                </a:solidFill>
+              </a:rPr>
+              <a:t>• Auditable: tag message records who deployed when</a:t>
+            </a:r>
+          </a:p>
+          <a:p>
+            <a:pPr>
+              <a:spcAft>
+                <a:spcPts val="600"/>
+              </a:spcAft>
+            </a:pPr>
+            <a:r>
+              <a:rPr sz="1300" b="0">
+                <a:solidFill>
+                  <a:srgbClr val="333333"/>
+                </a:solidFill>
+              </a:rPr>
+              <a:t>• Enables rollback: redeploy from tag at any time</a:t>
+            </a:r>
+          </a:p>
+          <a:p>
+            <a:pPr>
+              <a:spcAft>
+                <a:spcPts val="600"/>
+              </a:spcAft>
+            </a:pPr>
+            <a:r>
+              <a:rPr sz="1300" b="0">
+                <a:solidFill>
+                  <a:srgbClr val="333333"/>
+                </a:solidFill>
+              </a:rPr>
+              <a:t>• Patch releases get their own tag (sprint-12-patch1)</a:t>
             </a:r>
           </a:p>
         </p:txBody>

</xml_diff>